<commit_message>
Regenerate Hernandez Law proposal deck with the fixed layout engine
The pillar-detail text on slide 1 (e.g. "Owner handles most intake",
"Everything routes to owner") was overflowing its box into the findings
row below it — this deck was generated back in August, before the
auto-shrink/character-cap/font-embedding fixes landed in
Design Files/audit_pptx_template.py (merged in PR #34). Content is
unchanged; only the layout engine (font, shrink-to-fit, embedded
Poppins) was refreshed to the current template.

Co-Authored-By: Claude Sonnet 5 <noreply@anthropic.com>
Claude-Session: https://claude.ai/code/session_012yN1eEp3LKfYsZgkoZBU9D
</commit_message>
<xml_diff>
--- a/hernandez-law/Hernandez_Law_August 14, 2026_Proposal.pptx
+++ b/hernandez-law/Hernandez_Law_August 14, 2026_Proposal.pptx
@@ -1,6 +1,6 @@
 
 <file path=ppt/presentation.xml><?xml version="1.0" encoding="utf-8"?>
-<p:presentation xmlns:a="http://schemas.openxmlformats.org/drawingml/2006/main" xmlns:r="http://schemas.openxmlformats.org/officeDocument/2006/relationships" xmlns:p="http://schemas.openxmlformats.org/presentationml/2006/main" saveSubsetFonts="1" autoCompressPictures="0">
+<p:presentation xmlns:a="http://schemas.openxmlformats.org/drawingml/2006/main" xmlns:r="http://schemas.openxmlformats.org/officeDocument/2006/relationships" xmlns:p="http://schemas.openxmlformats.org/presentationml/2006/main" saveSubsetFonts="1" autoCompressPictures="0" embedTrueTypeFonts="1">
   <p:sldMasterIdLst>
     <p:sldMasterId id="2147483648" r:id="rId1"/>
   </p:sldMasterIdLst>
@@ -11,6 +11,14 @@
   </p:sldIdLst>
   <p:sldSz cx="9144000" cy="5143500" type="screen4x3"/>
   <p:notesSz cx="6858000" cy="9144000"/>
+  <p:embeddedFontLst>
+    <p:embeddedFont>
+      <p:font typeface="Poppins"/>
+      <p:regular r:id="rIdEmbedFont1"/>
+      <p:bold r:id="rIdEmbedFont2"/>
+      <p:italic r:id="rIdEmbedFont3"/>
+    </p:embeddedFont>
+  </p:embeddedFontLst>
   <p:defaultTextStyle>
     <a:defPPr>
       <a:defRPr lang="en-US"/>
@@ -3152,7 +3160,9 @@
           <a:noFill/>
         </p:spPr>
         <p:txBody>
-          <a:bodyPr wrap="square"/>
+          <a:bodyPr wrap="square">
+            <a:normAutofit/>
+          </a:bodyPr>
           <a:lstStyle/>
           <a:p>
             <a:pPr algn="l"/>
@@ -3185,7 +3195,9 @@
           <a:noFill/>
         </p:spPr>
         <p:txBody>
-          <a:bodyPr wrap="square"/>
+          <a:bodyPr wrap="square">
+            <a:normAutofit/>
+          </a:bodyPr>
           <a:lstStyle/>
           <a:p>
             <a:pPr algn="l"/>
@@ -3308,7 +3320,9 @@
           <a:noFill/>
         </p:spPr>
         <p:txBody>
-          <a:bodyPr wrap="square"/>
+          <a:bodyPr wrap="square">
+            <a:normAutofit/>
+          </a:bodyPr>
           <a:lstStyle/>
           <a:p>
             <a:pPr algn="ctr"/>
@@ -3341,7 +3355,9 @@
           <a:noFill/>
         </p:spPr>
         <p:txBody>
-          <a:bodyPr wrap="square"/>
+          <a:bodyPr wrap="square">
+            <a:normAutofit/>
+          </a:bodyPr>
           <a:lstStyle/>
           <a:p>
             <a:pPr algn="ctr"/>
@@ -3464,7 +3480,9 @@
           <a:noFill/>
         </p:spPr>
         <p:txBody>
-          <a:bodyPr wrap="square"/>
+          <a:bodyPr wrap="square">
+            <a:normAutofit/>
+          </a:bodyPr>
           <a:lstStyle/>
           <a:p>
             <a:pPr algn="l"/>
@@ -3497,7 +3515,9 @@
           <a:noFill/>
         </p:spPr>
         <p:txBody>
-          <a:bodyPr wrap="square"/>
+          <a:bodyPr wrap="square">
+            <a:normAutofit/>
+          </a:bodyPr>
           <a:lstStyle/>
           <a:p>
             <a:pPr algn="l"/>
@@ -3530,7 +3550,9 @@
           <a:noFill/>
         </p:spPr>
         <p:txBody>
-          <a:bodyPr wrap="square"/>
+          <a:bodyPr wrap="square">
+            <a:normAutofit/>
+          </a:bodyPr>
           <a:lstStyle/>
           <a:p>
             <a:pPr algn="l"/>
@@ -3653,7 +3675,9 @@
           <a:noFill/>
         </p:spPr>
         <p:txBody>
-          <a:bodyPr wrap="square"/>
+          <a:bodyPr wrap="square">
+            <a:normAutofit/>
+          </a:bodyPr>
           <a:lstStyle/>
           <a:p>
             <a:pPr algn="l"/>
@@ -3686,7 +3710,9 @@
           <a:noFill/>
         </p:spPr>
         <p:txBody>
-          <a:bodyPr wrap="square"/>
+          <a:bodyPr wrap="square">
+            <a:normAutofit/>
+          </a:bodyPr>
           <a:lstStyle/>
           <a:p>
             <a:pPr algn="l"/>
@@ -3719,7 +3745,9 @@
           <a:noFill/>
         </p:spPr>
         <p:txBody>
-          <a:bodyPr wrap="square"/>
+          <a:bodyPr wrap="square">
+            <a:normAutofit/>
+          </a:bodyPr>
           <a:lstStyle/>
           <a:p>
             <a:pPr algn="l"/>
@@ -3842,7 +3870,9 @@
           <a:noFill/>
         </p:spPr>
         <p:txBody>
-          <a:bodyPr wrap="square"/>
+          <a:bodyPr wrap="square">
+            <a:normAutofit/>
+          </a:bodyPr>
           <a:lstStyle/>
           <a:p>
             <a:pPr algn="l"/>
@@ -3875,7 +3905,9 @@
           <a:noFill/>
         </p:spPr>
         <p:txBody>
-          <a:bodyPr wrap="square"/>
+          <a:bodyPr wrap="square">
+            <a:normAutofit/>
+          </a:bodyPr>
           <a:lstStyle/>
           <a:p>
             <a:pPr algn="l"/>
@@ -3908,7 +3940,9 @@
           <a:noFill/>
         </p:spPr>
         <p:txBody>
-          <a:bodyPr wrap="square"/>
+          <a:bodyPr wrap="square">
+            <a:normAutofit/>
+          </a:bodyPr>
           <a:lstStyle/>
           <a:p>
             <a:pPr algn="l"/>
@@ -4031,7 +4065,9 @@
           <a:noFill/>
         </p:spPr>
         <p:txBody>
-          <a:bodyPr wrap="square"/>
+          <a:bodyPr wrap="square">
+            <a:normAutofit/>
+          </a:bodyPr>
           <a:lstStyle/>
           <a:p>
             <a:pPr algn="l"/>
@@ -4064,7 +4100,9 @@
           <a:noFill/>
         </p:spPr>
         <p:txBody>
-          <a:bodyPr wrap="square"/>
+          <a:bodyPr wrap="square">
+            <a:normAutofit/>
+          </a:bodyPr>
           <a:lstStyle/>
           <a:p>
             <a:pPr algn="l"/>
@@ -4097,7 +4135,9 @@
           <a:noFill/>
         </p:spPr>
         <p:txBody>
-          <a:bodyPr wrap="square"/>
+          <a:bodyPr wrap="square">
+            <a:normAutofit/>
+          </a:bodyPr>
           <a:lstStyle/>
           <a:p>
             <a:pPr algn="l"/>
@@ -4130,7 +4170,9 @@
           <a:noFill/>
         </p:spPr>
         <p:txBody>
-          <a:bodyPr wrap="square"/>
+          <a:bodyPr wrap="square">
+            <a:normAutofit/>
+          </a:bodyPr>
           <a:lstStyle/>
           <a:p>
             <a:pPr algn="l"/>
@@ -4253,7 +4295,9 @@
           <a:noFill/>
         </p:spPr>
         <p:txBody>
-          <a:bodyPr wrap="square"/>
+          <a:bodyPr wrap="square">
+            <a:normAutofit/>
+          </a:bodyPr>
           <a:lstStyle/>
           <a:p>
             <a:pPr algn="ctr"/>
@@ -4278,7 +4322,7 @@
         <p:spPr>
           <a:xfrm>
             <a:off x="676656" y="2286000"/>
-            <a:ext cx="4352544" cy="420624"/>
+            <a:ext cx="4352544" cy="475488"/>
           </a:xfrm>
           <a:prstGeom prst="rect">
             <a:avLst/>
@@ -4286,7 +4330,9 @@
           <a:noFill/>
         </p:spPr>
         <p:txBody>
-          <a:bodyPr wrap="square"/>
+          <a:bodyPr wrap="square">
+            <a:normAutofit/>
+          </a:bodyPr>
           <a:lstStyle/>
           <a:p>
             <a:pPr algn="l"/>
@@ -4409,7 +4455,9 @@
           <a:noFill/>
         </p:spPr>
         <p:txBody>
-          <a:bodyPr wrap="square"/>
+          <a:bodyPr wrap="square">
+            <a:normAutofit/>
+          </a:bodyPr>
           <a:lstStyle/>
           <a:p>
             <a:pPr algn="ctr"/>
@@ -4434,7 +4482,7 @@
         <p:spPr>
           <a:xfrm>
             <a:off x="676656" y="2907792"/>
-            <a:ext cx="4352544" cy="420624"/>
+            <a:ext cx="4352544" cy="475488"/>
           </a:xfrm>
           <a:prstGeom prst="rect">
             <a:avLst/>
@@ -4442,7 +4490,9 @@
           <a:noFill/>
         </p:spPr>
         <p:txBody>
-          <a:bodyPr wrap="square"/>
+          <a:bodyPr wrap="square">
+            <a:normAutofit/>
+          </a:bodyPr>
           <a:lstStyle/>
           <a:p>
             <a:pPr algn="l"/>
@@ -4565,7 +4615,9 @@
           <a:noFill/>
         </p:spPr>
         <p:txBody>
-          <a:bodyPr wrap="square"/>
+          <a:bodyPr wrap="square">
+            <a:normAutofit/>
+          </a:bodyPr>
           <a:lstStyle/>
           <a:p>
             <a:pPr algn="ctr"/>
@@ -4590,7 +4642,7 @@
         <p:spPr>
           <a:xfrm>
             <a:off x="676656" y="3529584"/>
-            <a:ext cx="4352544" cy="420624"/>
+            <a:ext cx="4352544" cy="475488"/>
           </a:xfrm>
           <a:prstGeom prst="rect">
             <a:avLst/>
@@ -4598,7 +4650,9 @@
           <a:noFill/>
         </p:spPr>
         <p:txBody>
-          <a:bodyPr wrap="square"/>
+          <a:bodyPr wrap="square">
+            <a:normAutofit/>
+          </a:bodyPr>
           <a:lstStyle/>
           <a:p>
             <a:pPr algn="l"/>
@@ -4721,7 +4775,9 @@
           <a:noFill/>
         </p:spPr>
         <p:txBody>
-          <a:bodyPr wrap="square"/>
+          <a:bodyPr wrap="square">
+            <a:normAutofit/>
+          </a:bodyPr>
           <a:lstStyle/>
           <a:p>
             <a:pPr algn="ctr"/>
@@ -4746,7 +4802,7 @@
         <p:spPr>
           <a:xfrm>
             <a:off x="676656" y="4151376"/>
-            <a:ext cx="4352544" cy="420624"/>
+            <a:ext cx="4352544" cy="475488"/>
           </a:xfrm>
           <a:prstGeom prst="rect">
             <a:avLst/>
@@ -4754,7 +4810,9 @@
           <a:noFill/>
         </p:spPr>
         <p:txBody>
-          <a:bodyPr wrap="square"/>
+          <a:bodyPr wrap="square">
+            <a:normAutofit/>
+          </a:bodyPr>
           <a:lstStyle/>
           <a:p>
             <a:pPr algn="l"/>
@@ -4922,7 +4980,9 @@
           <a:noFill/>
         </p:spPr>
         <p:txBody>
-          <a:bodyPr wrap="square"/>
+          <a:bodyPr wrap="square">
+            <a:normAutofit/>
+          </a:bodyPr>
           <a:lstStyle/>
           <a:p>
             <a:pPr algn="l"/>
@@ -4955,7 +5015,9 @@
           <a:noFill/>
         </p:spPr>
         <p:txBody>
-          <a:bodyPr wrap="square"/>
+          <a:bodyPr wrap="square">
+            <a:normAutofit/>
+          </a:bodyPr>
           <a:lstStyle/>
           <a:p>
             <a:pPr algn="l"/>
@@ -4988,7 +5050,9 @@
           <a:noFill/>
         </p:spPr>
         <p:txBody>
-          <a:bodyPr wrap="square"/>
+          <a:bodyPr wrap="square">
+            <a:normAutofit/>
+          </a:bodyPr>
           <a:lstStyle/>
           <a:p>
             <a:pPr algn="l"/>
@@ -5058,7 +5122,7 @@
         <p:spPr>
           <a:xfrm>
             <a:off x="5413248" y="2221991"/>
-            <a:ext cx="1828800" cy="219456"/>
+            <a:ext cx="1828800" cy="256032"/>
           </a:xfrm>
           <a:prstGeom prst="rect">
             <a:avLst/>
@@ -5066,7 +5130,9 @@
           <a:noFill/>
         </p:spPr>
         <p:txBody>
-          <a:bodyPr wrap="square"/>
+          <a:bodyPr wrap="square">
+            <a:normAutofit/>
+          </a:bodyPr>
           <a:lstStyle/>
           <a:p>
             <a:pPr algn="l"/>
@@ -5091,7 +5157,7 @@
         <p:spPr>
           <a:xfrm>
             <a:off x="7260336" y="2221991"/>
-            <a:ext cx="914400" cy="219456"/>
+            <a:ext cx="914400" cy="256032"/>
           </a:xfrm>
           <a:prstGeom prst="rect">
             <a:avLst/>
@@ -5099,7 +5165,9 @@
           <a:noFill/>
         </p:spPr>
         <p:txBody>
-          <a:bodyPr wrap="square"/>
+          <a:bodyPr wrap="square">
+            <a:normAutofit/>
+          </a:bodyPr>
           <a:lstStyle/>
           <a:p>
             <a:pPr algn="l"/>
@@ -5124,7 +5192,7 @@
         <p:spPr>
           <a:xfrm>
             <a:off x="8193024" y="2240279"/>
-            <a:ext cx="822960" cy="201168"/>
+            <a:ext cx="822960" cy="237744"/>
           </a:xfrm>
           <a:prstGeom prst="rect">
             <a:avLst/>
@@ -5132,7 +5200,9 @@
           <a:noFill/>
         </p:spPr>
         <p:txBody>
-          <a:bodyPr wrap="square"/>
+          <a:bodyPr wrap="square">
+            <a:normAutofit/>
+          </a:bodyPr>
           <a:lstStyle/>
           <a:p>
             <a:pPr algn="l"/>
@@ -5202,7 +5272,7 @@
         <p:spPr>
           <a:xfrm>
             <a:off x="5413248" y="2569463"/>
-            <a:ext cx="1828800" cy="219456"/>
+            <a:ext cx="1828800" cy="256032"/>
           </a:xfrm>
           <a:prstGeom prst="rect">
             <a:avLst/>
@@ -5210,7 +5280,9 @@
           <a:noFill/>
         </p:spPr>
         <p:txBody>
-          <a:bodyPr wrap="square"/>
+          <a:bodyPr wrap="square">
+            <a:normAutofit/>
+          </a:bodyPr>
           <a:lstStyle/>
           <a:p>
             <a:pPr algn="l"/>
@@ -5235,7 +5307,7 @@
         <p:spPr>
           <a:xfrm>
             <a:off x="7260336" y="2569463"/>
-            <a:ext cx="914400" cy="219456"/>
+            <a:ext cx="914400" cy="256032"/>
           </a:xfrm>
           <a:prstGeom prst="rect">
             <a:avLst/>
@@ -5243,7 +5315,9 @@
           <a:noFill/>
         </p:spPr>
         <p:txBody>
-          <a:bodyPr wrap="square"/>
+          <a:bodyPr wrap="square">
+            <a:normAutofit/>
+          </a:bodyPr>
           <a:lstStyle/>
           <a:p>
             <a:pPr algn="l"/>
@@ -5268,7 +5342,7 @@
         <p:spPr>
           <a:xfrm>
             <a:off x="8193024" y="2587751"/>
-            <a:ext cx="822960" cy="201168"/>
+            <a:ext cx="822960" cy="237744"/>
           </a:xfrm>
           <a:prstGeom prst="rect">
             <a:avLst/>
@@ -5276,7 +5350,9 @@
           <a:noFill/>
         </p:spPr>
         <p:txBody>
-          <a:bodyPr wrap="square"/>
+          <a:bodyPr wrap="square">
+            <a:normAutofit/>
+          </a:bodyPr>
           <a:lstStyle/>
           <a:p>
             <a:pPr algn="l"/>
@@ -5346,7 +5422,7 @@
         <p:spPr>
           <a:xfrm>
             <a:off x="5413248" y="2916936"/>
-            <a:ext cx="1828800" cy="219456"/>
+            <a:ext cx="1828800" cy="256032"/>
           </a:xfrm>
           <a:prstGeom prst="rect">
             <a:avLst/>
@@ -5354,7 +5430,9 @@
           <a:noFill/>
         </p:spPr>
         <p:txBody>
-          <a:bodyPr wrap="square"/>
+          <a:bodyPr wrap="square">
+            <a:normAutofit/>
+          </a:bodyPr>
           <a:lstStyle/>
           <a:p>
             <a:pPr algn="l"/>
@@ -5379,7 +5457,7 @@
         <p:spPr>
           <a:xfrm>
             <a:off x="7260336" y="2916936"/>
-            <a:ext cx="914400" cy="219456"/>
+            <a:ext cx="914400" cy="256032"/>
           </a:xfrm>
           <a:prstGeom prst="rect">
             <a:avLst/>
@@ -5387,7 +5465,9 @@
           <a:noFill/>
         </p:spPr>
         <p:txBody>
-          <a:bodyPr wrap="square"/>
+          <a:bodyPr wrap="square">
+            <a:normAutofit/>
+          </a:bodyPr>
           <a:lstStyle/>
           <a:p>
             <a:pPr algn="l"/>
@@ -5412,7 +5492,7 @@
         <p:spPr>
           <a:xfrm>
             <a:off x="8193024" y="2935224"/>
-            <a:ext cx="822960" cy="201168"/>
+            <a:ext cx="822960" cy="237744"/>
           </a:xfrm>
           <a:prstGeom prst="rect">
             <a:avLst/>
@@ -5420,7 +5500,9 @@
           <a:noFill/>
         </p:spPr>
         <p:txBody>
-          <a:bodyPr wrap="square"/>
+          <a:bodyPr wrap="square">
+            <a:normAutofit/>
+          </a:bodyPr>
           <a:lstStyle/>
           <a:p>
             <a:pPr algn="l"/>
@@ -5535,7 +5617,7 @@
         <p:spPr>
           <a:xfrm>
             <a:off x="5413248" y="3264408"/>
-            <a:ext cx="1828800" cy="219456"/>
+            <a:ext cx="1828800" cy="256032"/>
           </a:xfrm>
           <a:prstGeom prst="rect">
             <a:avLst/>
@@ -5543,7 +5625,9 @@
           <a:noFill/>
         </p:spPr>
         <p:txBody>
-          <a:bodyPr wrap="square"/>
+          <a:bodyPr wrap="square">
+            <a:normAutofit/>
+          </a:bodyPr>
           <a:lstStyle/>
           <a:p>
             <a:pPr algn="l"/>
@@ -5568,7 +5652,7 @@
         <p:spPr>
           <a:xfrm>
             <a:off x="7260336" y="3264408"/>
-            <a:ext cx="914400" cy="219456"/>
+            <a:ext cx="914400" cy="256032"/>
           </a:xfrm>
           <a:prstGeom prst="rect">
             <a:avLst/>
@@ -5576,7 +5660,9 @@
           <a:noFill/>
         </p:spPr>
         <p:txBody>
-          <a:bodyPr wrap="square"/>
+          <a:bodyPr wrap="square">
+            <a:normAutofit/>
+          </a:bodyPr>
           <a:lstStyle/>
           <a:p>
             <a:pPr algn="l"/>
@@ -5601,7 +5687,7 @@
         <p:spPr>
           <a:xfrm>
             <a:off x="8193024" y="3282696"/>
-            <a:ext cx="822960" cy="201168"/>
+            <a:ext cx="822960" cy="237744"/>
           </a:xfrm>
           <a:prstGeom prst="rect">
             <a:avLst/>
@@ -5609,7 +5695,9 @@
           <a:noFill/>
         </p:spPr>
         <p:txBody>
-          <a:bodyPr wrap="square"/>
+          <a:bodyPr wrap="square">
+            <a:normAutofit/>
+          </a:bodyPr>
           <a:lstStyle/>
           <a:p>
             <a:pPr algn="l"/>
@@ -5711,7 +5799,9 @@
           <a:noFill/>
         </p:spPr>
         <p:txBody>
-          <a:bodyPr wrap="square"/>
+          <a:bodyPr wrap="square">
+            <a:normAutofit/>
+          </a:bodyPr>
           <a:lstStyle/>
           <a:p>
             <a:pPr algn="l"/>
@@ -5744,7 +5834,9 @@
           <a:noFill/>
         </p:spPr>
         <p:txBody>
-          <a:bodyPr wrap="square"/>
+          <a:bodyPr wrap="square">
+            <a:normAutofit/>
+          </a:bodyPr>
           <a:lstStyle/>
           <a:p>
             <a:pPr algn="r"/>
@@ -5840,7 +5932,9 @@
           <a:noFill/>
         </p:spPr>
         <p:txBody>
-          <a:bodyPr wrap="square"/>
+          <a:bodyPr wrap="square">
+            <a:normAutofit/>
+          </a:bodyPr>
           <a:lstStyle/>
           <a:p>
             <a:pPr algn="l"/>
@@ -5873,7 +5967,9 @@
           <a:noFill/>
         </p:spPr>
         <p:txBody>
-          <a:bodyPr wrap="square"/>
+          <a:bodyPr wrap="square">
+            <a:normAutofit/>
+          </a:bodyPr>
           <a:lstStyle/>
           <a:p>
             <a:pPr algn="l"/>
@@ -5996,7 +6092,9 @@
           <a:noFill/>
         </p:spPr>
         <p:txBody>
-          <a:bodyPr wrap="square"/>
+          <a:bodyPr wrap="square">
+            <a:normAutofit/>
+          </a:bodyPr>
           <a:lstStyle/>
           <a:p>
             <a:pPr algn="l"/>
@@ -6029,7 +6127,9 @@
           <a:noFill/>
         </p:spPr>
         <p:txBody>
-          <a:bodyPr wrap="square"/>
+          <a:bodyPr wrap="square">
+            <a:normAutofit/>
+          </a:bodyPr>
           <a:lstStyle/>
           <a:p>
             <a:pPr algn="l"/>
@@ -6107,7 +6207,9 @@
           <a:noFill/>
         </p:spPr>
         <p:txBody>
-          <a:bodyPr wrap="square"/>
+          <a:bodyPr wrap="square">
+            <a:normAutofit/>
+          </a:bodyPr>
           <a:lstStyle/>
           <a:p>
             <a:pPr algn="l"/>
@@ -6140,7 +6242,9 @@
           <a:noFill/>
         </p:spPr>
         <p:txBody>
-          <a:bodyPr wrap="square"/>
+          <a:bodyPr wrap="square">
+            <a:normAutofit/>
+          </a:bodyPr>
           <a:lstStyle/>
           <a:p>
             <a:pPr algn="l"/>
@@ -6218,7 +6322,9 @@
           <a:noFill/>
         </p:spPr>
         <p:txBody>
-          <a:bodyPr wrap="square"/>
+          <a:bodyPr wrap="square">
+            <a:normAutofit/>
+          </a:bodyPr>
           <a:lstStyle/>
           <a:p>
             <a:pPr algn="l"/>
@@ -6251,7 +6357,9 @@
           <a:noFill/>
         </p:spPr>
         <p:txBody>
-          <a:bodyPr wrap="square"/>
+          <a:bodyPr wrap="square">
+            <a:normAutofit/>
+          </a:bodyPr>
           <a:lstStyle/>
           <a:p>
             <a:pPr algn="l"/>
@@ -6284,7 +6392,9 @@
           <a:noFill/>
         </p:spPr>
         <p:txBody>
-          <a:bodyPr wrap="square"/>
+          <a:bodyPr wrap="square">
+            <a:normAutofit/>
+          </a:bodyPr>
           <a:lstStyle/>
           <a:p>
             <a:pPr algn="l"/>
@@ -6407,7 +6517,9 @@
           <a:noFill/>
         </p:spPr>
         <p:txBody>
-          <a:bodyPr wrap="square"/>
+          <a:bodyPr wrap="square">
+            <a:normAutofit/>
+          </a:bodyPr>
           <a:lstStyle/>
           <a:p>
             <a:pPr algn="l"/>
@@ -6530,7 +6642,9 @@
           <a:noFill/>
         </p:spPr>
         <p:txBody>
-          <a:bodyPr wrap="square"/>
+          <a:bodyPr wrap="square">
+            <a:normAutofit/>
+          </a:bodyPr>
           <a:lstStyle/>
           <a:p>
             <a:pPr algn="l"/>
@@ -6653,7 +6767,9 @@
           <a:noFill/>
         </p:spPr>
         <p:txBody>
-          <a:bodyPr wrap="square"/>
+          <a:bodyPr wrap="square">
+            <a:normAutofit/>
+          </a:bodyPr>
           <a:lstStyle/>
           <a:p>
             <a:pPr algn="l"/>
@@ -6776,7 +6892,9 @@
           <a:noFill/>
         </p:spPr>
         <p:txBody>
-          <a:bodyPr wrap="square"/>
+          <a:bodyPr wrap="square">
+            <a:normAutofit/>
+          </a:bodyPr>
           <a:lstStyle/>
           <a:p>
             <a:pPr algn="l"/>
@@ -6899,7 +7017,9 @@
           <a:noFill/>
         </p:spPr>
         <p:txBody>
-          <a:bodyPr wrap="square"/>
+          <a:bodyPr wrap="square">
+            <a:normAutofit/>
+          </a:bodyPr>
           <a:lstStyle/>
           <a:p>
             <a:pPr algn="l"/>
@@ -6977,7 +7097,9 @@
           <a:noFill/>
         </p:spPr>
         <p:txBody>
-          <a:bodyPr wrap="square"/>
+          <a:bodyPr wrap="square">
+            <a:normAutofit/>
+          </a:bodyPr>
           <a:lstStyle/>
           <a:p>
             <a:pPr algn="l"/>
@@ -7010,7 +7132,9 @@
           <a:noFill/>
         </p:spPr>
         <p:txBody>
-          <a:bodyPr wrap="square"/>
+          <a:bodyPr wrap="square">
+            <a:normAutofit/>
+          </a:bodyPr>
           <a:lstStyle/>
           <a:p>
             <a:pPr algn="l"/>
@@ -7043,7 +7167,9 @@
           <a:noFill/>
         </p:spPr>
         <p:txBody>
-          <a:bodyPr wrap="square"/>
+          <a:bodyPr wrap="square">
+            <a:normAutofit/>
+          </a:bodyPr>
           <a:lstStyle/>
           <a:p>
             <a:pPr algn="l"/>
@@ -7166,7 +7292,9 @@
           <a:noFill/>
         </p:spPr>
         <p:txBody>
-          <a:bodyPr wrap="square"/>
+          <a:bodyPr wrap="square">
+            <a:normAutofit/>
+          </a:bodyPr>
           <a:lstStyle/>
           <a:p>
             <a:pPr algn="l"/>
@@ -7289,7 +7417,9 @@
           <a:noFill/>
         </p:spPr>
         <p:txBody>
-          <a:bodyPr wrap="square"/>
+          <a:bodyPr wrap="square">
+            <a:normAutofit/>
+          </a:bodyPr>
           <a:lstStyle/>
           <a:p>
             <a:pPr algn="l"/>
@@ -7412,7 +7542,9 @@
           <a:noFill/>
         </p:spPr>
         <p:txBody>
-          <a:bodyPr wrap="square"/>
+          <a:bodyPr wrap="square">
+            <a:normAutofit/>
+          </a:bodyPr>
           <a:lstStyle/>
           <a:p>
             <a:pPr algn="l"/>
@@ -7535,7 +7667,9 @@
           <a:noFill/>
         </p:spPr>
         <p:txBody>
-          <a:bodyPr wrap="square"/>
+          <a:bodyPr wrap="square">
+            <a:normAutofit/>
+          </a:bodyPr>
           <a:lstStyle/>
           <a:p>
             <a:pPr algn="l"/>
@@ -7658,7 +7792,9 @@
           <a:noFill/>
         </p:spPr>
         <p:txBody>
-          <a:bodyPr wrap="square"/>
+          <a:bodyPr wrap="square">
+            <a:normAutofit/>
+          </a:bodyPr>
           <a:lstStyle/>
           <a:p>
             <a:pPr algn="l"/>
@@ -7736,7 +7872,9 @@
           <a:noFill/>
         </p:spPr>
         <p:txBody>
-          <a:bodyPr wrap="square"/>
+          <a:bodyPr wrap="square">
+            <a:normAutofit/>
+          </a:bodyPr>
           <a:lstStyle/>
           <a:p>
             <a:pPr algn="l"/>
@@ -7769,7 +7907,9 @@
           <a:noFill/>
         </p:spPr>
         <p:txBody>
-          <a:bodyPr wrap="square"/>
+          <a:bodyPr wrap="square">
+            <a:normAutofit/>
+          </a:bodyPr>
           <a:lstStyle/>
           <a:p>
             <a:pPr algn="l"/>
@@ -7802,7 +7942,9 @@
           <a:noFill/>
         </p:spPr>
         <p:txBody>
-          <a:bodyPr wrap="square"/>
+          <a:bodyPr wrap="square">
+            <a:normAutofit/>
+          </a:bodyPr>
           <a:lstStyle/>
           <a:p>
             <a:pPr algn="l"/>
@@ -7925,7 +8067,9 @@
           <a:noFill/>
         </p:spPr>
         <p:txBody>
-          <a:bodyPr wrap="square"/>
+          <a:bodyPr wrap="square">
+            <a:normAutofit/>
+          </a:bodyPr>
           <a:lstStyle/>
           <a:p>
             <a:pPr algn="l"/>
@@ -8048,7 +8192,9 @@
           <a:noFill/>
         </p:spPr>
         <p:txBody>
-          <a:bodyPr wrap="square"/>
+          <a:bodyPr wrap="square">
+            <a:normAutofit/>
+          </a:bodyPr>
           <a:lstStyle/>
           <a:p>
             <a:pPr algn="l"/>
@@ -8171,7 +8317,9 @@
           <a:noFill/>
         </p:spPr>
         <p:txBody>
-          <a:bodyPr wrap="square"/>
+          <a:bodyPr wrap="square">
+            <a:normAutofit/>
+          </a:bodyPr>
           <a:lstStyle/>
           <a:p>
             <a:pPr algn="l"/>
@@ -8294,7 +8442,9 @@
           <a:noFill/>
         </p:spPr>
         <p:txBody>
-          <a:bodyPr wrap="square"/>
+          <a:bodyPr wrap="square">
+            <a:normAutofit/>
+          </a:bodyPr>
           <a:lstStyle/>
           <a:p>
             <a:pPr algn="l"/>
@@ -8417,7 +8567,9 @@
           <a:noFill/>
         </p:spPr>
         <p:txBody>
-          <a:bodyPr wrap="square"/>
+          <a:bodyPr wrap="square">
+            <a:normAutofit/>
+          </a:bodyPr>
           <a:lstStyle/>
           <a:p>
             <a:pPr algn="l"/>
@@ -8519,7 +8671,9 @@
           <a:noFill/>
         </p:spPr>
         <p:txBody>
-          <a:bodyPr wrap="square"/>
+          <a:bodyPr wrap="square">
+            <a:normAutofit/>
+          </a:bodyPr>
           <a:lstStyle/>
           <a:p>
             <a:pPr algn="l"/>
@@ -8552,7 +8706,9 @@
           <a:noFill/>
         </p:spPr>
         <p:txBody>
-          <a:bodyPr wrap="square"/>
+          <a:bodyPr wrap="square">
+            <a:normAutofit/>
+          </a:bodyPr>
           <a:lstStyle/>
           <a:p>
             <a:pPr algn="r"/>
@@ -8648,7 +8804,9 @@
           <a:noFill/>
         </p:spPr>
         <p:txBody>
-          <a:bodyPr wrap="square"/>
+          <a:bodyPr wrap="square">
+            <a:normAutofit/>
+          </a:bodyPr>
           <a:lstStyle/>
           <a:p>
             <a:pPr algn="l"/>
@@ -8681,7 +8839,9 @@
           <a:noFill/>
         </p:spPr>
         <p:txBody>
-          <a:bodyPr wrap="square"/>
+          <a:bodyPr wrap="square">
+            <a:normAutofit/>
+          </a:bodyPr>
           <a:lstStyle/>
           <a:p>
             <a:pPr algn="l"/>
@@ -8804,7 +8964,9 @@
           <a:noFill/>
         </p:spPr>
         <p:txBody>
-          <a:bodyPr wrap="square"/>
+          <a:bodyPr wrap="square">
+            <a:normAutofit/>
+          </a:bodyPr>
           <a:lstStyle/>
           <a:p>
             <a:pPr algn="l"/>
@@ -8837,7 +8999,9 @@
           <a:noFill/>
         </p:spPr>
         <p:txBody>
-          <a:bodyPr wrap="square"/>
+          <a:bodyPr wrap="square">
+            <a:normAutofit/>
+          </a:bodyPr>
           <a:lstStyle/>
           <a:p>
             <a:pPr algn="l"/>
@@ -8870,7 +9034,9 @@
           <a:noFill/>
         </p:spPr>
         <p:txBody>
-          <a:bodyPr wrap="square"/>
+          <a:bodyPr wrap="square">
+            <a:normAutofit/>
+          </a:bodyPr>
           <a:lstStyle/>
           <a:p>
             <a:pPr algn="l"/>
@@ -8903,7 +9069,9 @@
           <a:noFill/>
         </p:spPr>
         <p:txBody>
-          <a:bodyPr wrap="square"/>
+          <a:bodyPr wrap="square">
+            <a:normAutofit/>
+          </a:bodyPr>
           <a:lstStyle/>
           <a:p>
             <a:pPr algn="l"/>
@@ -8981,7 +9149,9 @@
           <a:noFill/>
         </p:spPr>
         <p:txBody>
-          <a:bodyPr wrap="square"/>
+          <a:bodyPr wrap="square">
+            <a:normAutofit/>
+          </a:bodyPr>
           <a:lstStyle/>
           <a:p>
             <a:pPr algn="l"/>
@@ -9059,7 +9229,9 @@
           <a:noFill/>
         </p:spPr>
         <p:txBody>
-          <a:bodyPr wrap="square"/>
+          <a:bodyPr wrap="square">
+            <a:normAutofit/>
+          </a:bodyPr>
           <a:lstStyle/>
           <a:p>
             <a:pPr algn="l"/>
@@ -9092,7 +9264,9 @@
           <a:noFill/>
         </p:spPr>
         <p:txBody>
-          <a:bodyPr wrap="square"/>
+          <a:bodyPr wrap="square">
+            <a:normAutofit/>
+          </a:bodyPr>
           <a:lstStyle/>
           <a:p>
             <a:pPr algn="l"/>
@@ -9125,7 +9299,9 @@
           <a:noFill/>
         </p:spPr>
         <p:txBody>
-          <a:bodyPr wrap="square"/>
+          <a:bodyPr wrap="square">
+            <a:normAutofit/>
+          </a:bodyPr>
           <a:lstStyle/>
           <a:p>
             <a:pPr algn="l"/>
@@ -9203,7 +9379,9 @@
           <a:noFill/>
         </p:spPr>
         <p:txBody>
-          <a:bodyPr wrap="square"/>
+          <a:bodyPr wrap="square">
+            <a:normAutofit/>
+          </a:bodyPr>
           <a:lstStyle/>
           <a:p>
             <a:pPr algn="l"/>
@@ -9281,7 +9459,9 @@
           <a:noFill/>
         </p:spPr>
         <p:txBody>
-          <a:bodyPr wrap="square"/>
+          <a:bodyPr wrap="square">
+            <a:normAutofit/>
+          </a:bodyPr>
           <a:lstStyle/>
           <a:p>
             <a:pPr algn="l"/>
@@ -9314,7 +9494,9 @@
           <a:noFill/>
         </p:spPr>
         <p:txBody>
-          <a:bodyPr wrap="square"/>
+          <a:bodyPr wrap="square">
+            <a:normAutofit/>
+          </a:bodyPr>
           <a:lstStyle/>
           <a:p>
             <a:pPr algn="l"/>
@@ -9347,7 +9529,9 @@
           <a:noFill/>
         </p:spPr>
         <p:txBody>
-          <a:bodyPr wrap="square"/>
+          <a:bodyPr wrap="square">
+            <a:normAutofit/>
+          </a:bodyPr>
           <a:lstStyle/>
           <a:p>
             <a:pPr algn="l"/>
@@ -9425,7 +9609,9 @@
           <a:noFill/>
         </p:spPr>
         <p:txBody>
-          <a:bodyPr wrap="square"/>
+          <a:bodyPr wrap="square">
+            <a:normAutofit/>
+          </a:bodyPr>
           <a:lstStyle/>
           <a:p>
             <a:pPr algn="l"/>
@@ -9458,7 +9644,9 @@
           <a:noFill/>
         </p:spPr>
         <p:txBody>
-          <a:bodyPr wrap="square"/>
+          <a:bodyPr wrap="square">
+            <a:normAutofit/>
+          </a:bodyPr>
           <a:lstStyle/>
           <a:p>
             <a:pPr algn="l"/>
@@ -9491,7 +9679,9 @@
           <a:noFill/>
         </p:spPr>
         <p:txBody>
-          <a:bodyPr wrap="square"/>
+          <a:bodyPr wrap="square">
+            <a:normAutofit/>
+          </a:bodyPr>
           <a:lstStyle/>
           <a:p>
             <a:pPr algn="l"/>
@@ -9524,7 +9714,9 @@
           <a:noFill/>
         </p:spPr>
         <p:txBody>
-          <a:bodyPr wrap="square"/>
+          <a:bodyPr wrap="square">
+            <a:normAutofit/>
+          </a:bodyPr>
           <a:lstStyle/>
           <a:p>
             <a:pPr algn="l"/>
@@ -9557,7 +9749,9 @@
           <a:noFill/>
         </p:spPr>
         <p:txBody>
-          <a:bodyPr wrap="square"/>
+          <a:bodyPr wrap="square">
+            <a:normAutofit/>
+          </a:bodyPr>
           <a:lstStyle/>
           <a:p>
             <a:pPr algn="l"/>
@@ -9635,7 +9829,9 @@
           <a:noFill/>
         </p:spPr>
         <p:txBody>
-          <a:bodyPr wrap="square"/>
+          <a:bodyPr wrap="square">
+            <a:normAutofit/>
+          </a:bodyPr>
           <a:lstStyle/>
           <a:p>
             <a:pPr algn="l"/>
@@ -9668,7 +9864,9 @@
           <a:noFill/>
         </p:spPr>
         <p:txBody>
-          <a:bodyPr wrap="square"/>
+          <a:bodyPr wrap="square">
+            <a:normAutofit/>
+          </a:bodyPr>
           <a:lstStyle/>
           <a:p>
             <a:pPr algn="l"/>
@@ -9746,7 +9944,9 @@
           <a:noFill/>
         </p:spPr>
         <p:txBody>
-          <a:bodyPr wrap="square"/>
+          <a:bodyPr wrap="square">
+            <a:normAutofit/>
+          </a:bodyPr>
           <a:lstStyle/>
           <a:p>
             <a:pPr algn="l"/>
@@ -9779,7 +9979,9 @@
           <a:noFill/>
         </p:spPr>
         <p:txBody>
-          <a:bodyPr wrap="square"/>
+          <a:bodyPr wrap="square">
+            <a:normAutofit/>
+          </a:bodyPr>
           <a:lstStyle/>
           <a:p>
             <a:pPr algn="l"/>
@@ -9857,7 +10059,9 @@
           <a:noFill/>
         </p:spPr>
         <p:txBody>
-          <a:bodyPr wrap="square"/>
+          <a:bodyPr wrap="square">
+            <a:normAutofit/>
+          </a:bodyPr>
           <a:lstStyle/>
           <a:p>
             <a:pPr algn="l"/>
@@ -9890,7 +10094,9 @@
           <a:noFill/>
         </p:spPr>
         <p:txBody>
-          <a:bodyPr wrap="square"/>
+          <a:bodyPr wrap="square">
+            <a:normAutofit/>
+          </a:bodyPr>
           <a:lstStyle/>
           <a:p>
             <a:pPr algn="l"/>
@@ -9968,7 +10174,9 @@
           <a:noFill/>
         </p:spPr>
         <p:txBody>
-          <a:bodyPr wrap="square"/>
+          <a:bodyPr wrap="square">
+            <a:normAutofit/>
+          </a:bodyPr>
           <a:lstStyle/>
           <a:p>
             <a:pPr algn="l"/>
@@ -10001,7 +10209,9 @@
           <a:noFill/>
         </p:spPr>
         <p:txBody>
-          <a:bodyPr wrap="square"/>
+          <a:bodyPr wrap="square">
+            <a:normAutofit/>
+          </a:bodyPr>
           <a:lstStyle/>
           <a:p>
             <a:pPr algn="l"/>
@@ -10079,7 +10289,9 @@
           <a:noFill/>
         </p:spPr>
         <p:txBody>
-          <a:bodyPr wrap="square"/>
+          <a:bodyPr wrap="square">
+            <a:normAutofit/>
+          </a:bodyPr>
           <a:lstStyle/>
           <a:p>
             <a:pPr algn="l"/>
@@ -10112,7 +10324,9 @@
           <a:noFill/>
         </p:spPr>
         <p:txBody>
-          <a:bodyPr wrap="square"/>
+          <a:bodyPr wrap="square">
+            <a:normAutofit/>
+          </a:bodyPr>
           <a:lstStyle/>
           <a:p>
             <a:pPr algn="l"/>
@@ -10190,7 +10404,9 @@
           <a:noFill/>
         </p:spPr>
         <p:txBody>
-          <a:bodyPr wrap="square"/>
+          <a:bodyPr wrap="square">
+            <a:normAutofit/>
+          </a:bodyPr>
           <a:lstStyle/>
           <a:p>
             <a:pPr algn="ctr"/>
@@ -10292,7 +10508,9 @@
           <a:noFill/>
         </p:spPr>
         <p:txBody>
-          <a:bodyPr wrap="square"/>
+          <a:bodyPr wrap="square">
+            <a:normAutofit/>
+          </a:bodyPr>
           <a:lstStyle/>
           <a:p>
             <a:pPr algn="l"/>
@@ -10325,7 +10543,9 @@
           <a:noFill/>
         </p:spPr>
         <p:txBody>
-          <a:bodyPr wrap="square"/>
+          <a:bodyPr wrap="square">
+            <a:normAutofit/>
+          </a:bodyPr>
           <a:lstStyle/>
           <a:p>
             <a:pPr algn="r"/>

</xml_diff>

<commit_message>
Restyle the client's competitor-table row from red to navy/ocean-blue
The client's own row was styled in red (pink background, red bold
text) to stand out as a "you are here" marker, but that reads as an
error/warning next to the neutral competitor rows above it rather than
a highlight. Switched it to the same navy/ocean-blue language already
used for the "YOU ARE HERE" stage strip elsewhere on the slide, so the
two highlights read consistently.

Regenerated the Hernandez Law deck to pick up the new styling.

Co-Authored-By: Claude Sonnet 5 <noreply@anthropic.com>
Claude-Session: https://claude.ai/code/session_012yN1eEp3LKfYsZgkoZBU9D
</commit_message>
<xml_diff>
--- a/hernandez-law/Hernandez_Law_August 14, 2026_Proposal.pptx
+++ b/hernandez-law/Hernandez_Law_August 14, 2026_Proposal.pptx
@@ -5533,7 +5533,7 @@
             <a:avLst/>
           </a:prstGeom>
           <a:solidFill>
-            <a:srgbClr val="FFF0F0"/>
+            <a:srgbClr val="E3F4FA"/>
           </a:solidFill>
           <a:ln>
             <a:solidFill>
@@ -5578,7 +5578,7 @@
             <a:avLst/>
           </a:prstGeom>
           <a:solidFill>
-            <a:srgbClr val="C0392B"/>
+            <a:srgbClr val="0091C9"/>
           </a:solidFill>
           <a:ln>
             <a:solidFill>
@@ -5634,7 +5634,7 @@
             <a:r>
               <a:rPr sz="900" b="1" i="0">
                 <a:solidFill>
-                  <a:srgbClr val="C0392B"/>
+                  <a:srgbClr val="003A59"/>
                 </a:solidFill>
                 <a:latin typeface="Poppins"/>
               </a:rPr>
@@ -5669,7 +5669,7 @@
             <a:r>
               <a:rPr sz="800" b="1" i="0">
                 <a:solidFill>
-                  <a:srgbClr val="C0392B"/>
+                  <a:srgbClr val="0091C9"/>
                 </a:solidFill>
                 <a:latin typeface="Poppins"/>
               </a:rPr>

</xml_diff>